<commit_message>
feat(anr): 第3題依卷面重佈(深邊緣幾何)+ UE 選網遵守 cellBarred(TS 38.304)
Q3 場景:實測 azimuth_deg 不旋轉水平場型(場型固定峰±x/零陷±z,已列 backlog),
改用幾何佈局 —— s28(0,0) 讓駐點 (0,−420) 落進 −z 零陷、n51(0,250)/n52(0,450)
排同軸更遠(比 serving 更弱,不搶駐留不觸發 A3)、n91(−350,−70) 落 45° 側。
live E2 實測:serving −107.5(≤−105 ✓)、增益 +19.8dB(≥10 ✓,卷面 18.5)、
bySourceCell 單一 s28_c0、NRT 查無 s28→n91 ✓。

順帶修真缺陷:UE 端 IDLE 選網不看 cellBarred(CU 重建有擋),導致 UE 自己
駐到 barred 的 n91 上、深邊緣狀態崩掉。CU servingCells 補 barred 欄位,
UE cell_selection 排除之(TS 38.304 §5.2.4.1)。

Co-Authored-By: Claude Fable 5 <noreply@anthropic.com>
Claude-Session: https://claude.ai/code/session_012UT99ZBQLFpnCjPVALSd9E
</commit_message>
<xml_diff>
--- a/docs/report/8_27_進度報告_v10十二題.pptx
+++ b/docs/report/8_27_進度報告_v10十二題.pptx
@@ -13430,18 +13430,69 @@
           <a:p>
             <a:pPr>
               <a:spcAft>
-                <a:spcPts val="200"/>
+                <a:spcPts val="300"/>
               </a:spcAft>
             </a:pPr>
             <a:r>
-              <a:rPr sz="900" b="0">
+              <a:rPr sz="800" b="0">
                 <a:solidFill>
                   <a:srgbClr val="222A30"/>
                 </a:solidFill>
                 <a:latin typeface="Arial"/>
                 <a:ea typeface="Microsoft JhengHei"/>
               </a:rPr>
-              <a:t>SMO + 抑制 ADD + Format 3 群組換手(condition PCI → owned CGI)→ twc ≤0.05 行為確認</a:t>
+              <a:t>① 先送 SMO:PCI 撞號要靠重新規劃才能根治,xApp 只能止血</a:t>
+            </a:r>
+          </a:p>
+          <a:p>
+            <a:pPr>
+              <a:spcAft>
+                <a:spcPts val="300"/>
+              </a:spcAft>
+            </a:pPr>
+            <a:r>
+              <a:rPr sz="800" b="0">
+                <a:solidFill>
+                  <a:srgbClr val="222A30"/>
+                </a:solidFill>
+                <a:latin typeface="Arial"/>
+                <a:ea typeface="Microsoft JhengHei"/>
+              </a:rPr>
+              <a:t>② 撞號期間不建關係(會建到錯的那一顆)</a:t>
+            </a:r>
+          </a:p>
+          <a:p>
+            <a:pPr>
+              <a:spcAft>
+                <a:spcPts val="300"/>
+              </a:spcAft>
+            </a:pPr>
+            <a:r>
+              <a:rPr sz="800" b="0">
+                <a:solidFill>
+                  <a:srgbClr val="222A30"/>
+                </a:solidFill>
+                <a:latin typeface="Arial"/>
+                <a:ea typeface="Microsoft JhengHei"/>
+              </a:rPr>
+              <a:t>③ 改用「群組換手」:條件寫 PCI、目標直接指定正確的 CGI,繞過歧義</a:t>
+            </a:r>
+          </a:p>
+          <a:p>
+            <a:pPr>
+              <a:spcAft>
+                <a:spcPts val="300"/>
+              </a:spcAft>
+            </a:pPr>
+            <a:r>
+              <a:rPr sz="800" b="0">
+                <a:solidFill>
+                  <a:srgbClr val="222A30"/>
+                </a:solidFill>
+                <a:latin typeface="Arial"/>
+                <a:ea typeface="Microsoft JhengHei"/>
+              </a:rPr>
+              <a:t>④ 確認換錯 cell 的比率 ≤5% 才算有效</a:t>
             </a:r>
           </a:p>
           <a:p>
@@ -13548,6 +13599,69 @@
                 <a:ea typeface="Microsoft JhengHei"/>
               </a:rPr>
               <a:t>02:09:35 EXECUTED 5/5 → twc=0;NO_MATCH=掃動 UE 正常,重試即可</a:t>
+            </a:r>
+          </a:p>
+        </p:txBody>
+      </p:sp>
+      <p:sp>
+        <p:nvSpPr>
+          <p:cNvPr id="7" name="SimInjection"/>
+          <p:cNvSpPr/>
+          <p:nvPr/>
+        </p:nvSpPr>
+        <p:spPr>
+          <a:xfrm>
+            <a:off x="320040" y="4025000"/>
+            <a:ext cx="5577840" cy="800000"/>
+          </a:xfrm>
+          <a:prstGeom prst="roundRect">
+            <a:avLst/>
+          </a:prstGeom>
+          <a:solidFill>
+            <a:srgbClr val="44546A"/>
+          </a:solidFill>
+          <a:ln w="12700">
+            <a:solidFill>
+              <a:srgbClr val="1CADE4"/>
+            </a:solidFill>
+          </a:ln>
+          <a:effectLst/>
+        </p:spPr>
+        <p:txBody>
+          <a:bodyPr rtlCol="0" anchor="ctr" wrap="square" tIns="45720" bIns="45720"/>
+          <a:lstStyle/>
+          <a:p>
+            <a:pPr algn="ctr">
+              <a:spcAft>
+                <a:spcPts val="200"/>
+              </a:spcAft>
+            </a:pPr>
+            <a:r>
+              <a:rPr sz="1000" b="1">
+                <a:solidFill>
+                  <a:srgbClr val="FFD966"/>
+                </a:solidFill>
+                <a:latin typeface="Arial"/>
+                <a:ea typeface="Microsoft JhengHei"/>
+              </a:rPr>
+              <a:t>sim 端怎麼把這個病做出來</a:t>
+            </a:r>
+          </a:p>
+          <a:p>
+            <a:pPr>
+              <a:spcAft>
+                <a:spcPts val="200"/>
+              </a:spcAft>
+            </a:pPr>
+            <a:r>
+              <a:rPr sz="850" b="0">
+                <a:solidFill>
+                  <a:srgbClr val="FFFFFF"/>
+                </a:solidFill>
+                <a:latin typeface="Arial"/>
+                <a:ea typeface="Microsoft JhengHei"/>
+              </a:rPr>
+              <a:t>場景直接讓兩顆 cell 共用 pci=7(west_c7 / east_c7)造成撞號;佈病再把來源 mid_c0 的 NRT 只留 east 一條(刪掉 west),造出「owned 唯一」這個敢下手的前提。</a:t>
             </a:r>
           </a:p>
         </p:txBody>
@@ -14010,18 +14124,69 @@
           <a:p>
             <a:pPr>
               <a:spcAft>
-                <a:spcPts val="200"/>
+                <a:spcPts val="300"/>
               </a:spcAft>
             </a:pPr>
             <a:r>
-              <a:rPr sz="900" b="0">
+              <a:rPr sz="800" b="0">
                 <a:solidFill>
                   <a:srgbClr val="222A30"/>
                 </a:solidFill>
                 <a:latin typeface="Arial"/>
                 <a:ea typeface="Microsoft JhengHei"/>
               </a:rPr>
-              <a:t>set xnBlocklist(止血)→ SMO(TNL 屬管理面)→ xn=true 觸發 clear → 行為確認(1800s 窗)</a:t>
+              <a:t>① 設 xnBlocklist:關係留著,但禁止拿它當換手目標(止血,不拆線)</a:t>
+            </a:r>
+          </a:p>
+          <a:p>
+            <a:pPr>
+              <a:spcAft>
+                <a:spcPts val="300"/>
+              </a:spcAft>
+            </a:pPr>
+            <a:r>
+              <a:rPr sz="800" b="0">
+                <a:solidFill>
+                  <a:srgbClr val="222A30"/>
+                </a:solidFill>
+                <a:latin typeface="Arial"/>
+                <a:ea typeface="Microsoft JhengHei"/>
+              </a:rPr>
+              <a:t>② Xn 是管理面的事,xApp 修不了 → 送 SMO 請人修</a:t>
+            </a:r>
+          </a:p>
+          <a:p>
+            <a:pPr>
+              <a:spcAft>
+                <a:spcPts val="300"/>
+              </a:spcAft>
+            </a:pPr>
+            <a:r>
+              <a:rPr sz="800" b="0">
+                <a:solidFill>
+                  <a:srgbClr val="222A30"/>
+                </a:solidFill>
+                <a:latin typeface="Arial"/>
+                <a:ea typeface="Microsoft JhengHei"/>
+              </a:rPr>
+              <a:t>③ 看到 Xn 恢復就解除封鎖</a:t>
+            </a:r>
+          </a:p>
+          <a:p>
+            <a:pPr>
+              <a:spcAft>
+                <a:spcPts val="300"/>
+              </a:spcAft>
+            </a:pPr>
+            <a:r>
+              <a:rPr sz="800" b="0">
+                <a:solidFill>
+                  <a:srgbClr val="222A30"/>
+                </a:solidFill>
+                <a:latin typeface="Arial"/>
+                <a:ea typeface="Microsoft JhengHei"/>
+              </a:rPr>
+              <a:t>④ 用「換手成功率回升」證明真的好了 —— 旗標本身不算證據</a:t>
             </a:r>
           </a:p>
           <a:p>
@@ -14128,6 +14293,69 @@
                 <a:ea typeface="Microsoft JhengHei"/>
               </a:rPr>
               <a:t>SET(att 5→0)→ CLEAR → 17:07:10 RECOVERED succ=0.9</a:t>
+            </a:r>
+          </a:p>
+        </p:txBody>
+      </p:sp>
+      <p:sp>
+        <p:nvSpPr>
+          <p:cNvPr id="7" name="SimInjection"/>
+          <p:cNvSpPr/>
+          <p:nvPr/>
+        </p:nvSpPr>
+        <p:spPr>
+          <a:xfrm>
+            <a:off x="320040" y="4025000"/>
+            <a:ext cx="5577840" cy="800000"/>
+          </a:xfrm>
+          <a:prstGeom prst="roundRect">
+            <a:avLst/>
+          </a:prstGeom>
+          <a:solidFill>
+            <a:srgbClr val="44546A"/>
+          </a:solidFill>
+          <a:ln w="12700">
+            <a:solidFill>
+              <a:srgbClr val="1CADE4"/>
+            </a:solidFill>
+          </a:ln>
+          <a:effectLst/>
+        </p:spPr>
+        <p:txBody>
+          <a:bodyPr rtlCol="0" anchor="ctr" wrap="square" tIns="45720" bIns="45720"/>
+          <a:lstStyle/>
+          <a:p>
+            <a:pPr algn="ctr">
+              <a:spcAft>
+                <a:spcPts val="200"/>
+              </a:spcAft>
+            </a:pPr>
+            <a:r>
+              <a:rPr sz="1000" b="1">
+                <a:solidFill>
+                  <a:srgbClr val="FFD966"/>
+                </a:solidFill>
+                <a:latin typeface="Arial"/>
+                <a:ea typeface="Microsoft JhengHei"/>
+              </a:rPr>
+              <a:t>sim 端怎麼把這個病做出來</a:t>
+            </a:r>
+          </a:p>
+          <a:p>
+            <a:pPr>
+              <a:spcAft>
+                <a:spcPts val="200"/>
+              </a:spcAft>
+            </a:pPr>
+            <a:r>
+              <a:rPr sz="850" b="0">
+                <a:solidFill>
+                  <a:srgbClr val="FFFFFF"/>
+                </a:solidFill>
+                <a:latin typeface="Arial"/>
+                <a:ea typeface="Microsoft JhengHei"/>
+              </a:rPr>
+              <a:t>關係留著,只把 xn_x2_established 改成 false。換手 executor 一看 Xn 未通,就在「準備階段」回 TXnRELOCprepExpiry —— 連 Handover Request 都送不出去(這是與第 7 題的鑑別線)。</a:t>
             </a:r>
           </a:p>
         </p:txBody>
@@ -14590,18 +14818,69 @@
           <a:p>
             <a:pPr>
               <a:spcAft>
-                <a:spcPts val="200"/>
+                <a:spcPts val="300"/>
               </a:spcAft>
             </a:pPr>
             <a:r>
-              <a:rPr sz="900" b="0">
+              <a:rPr sz="800" b="0">
                 <a:solidFill>
                   <a:srgbClr val="222A30"/>
                 </a:solidFill>
                 <a:latin typeface="Arial"/>
                 <a:ea typeface="Microsoft JhengHei"/>
               </a:rPr>
-              <a:t>hoBlocklist+noRemove 成對 → L4:到期探測、失敗再現重封(倍增封頂 4×)、乾淨+流量背書才恢復</a:t>
+              <a:t>① 一次設兩個旗標:禁止換過去(hoBlocklist)+ 禁止被刪掉(noRemove,保住失敗歷史)</a:t>
+            </a:r>
+          </a:p>
+          <a:p>
+            <a:pPr>
+              <a:spcAft>
+                <a:spcPts val="300"/>
+              </a:spcAft>
+            </a:pPr>
+            <a:r>
+              <a:rPr sz="800" b="0">
+                <a:solidFill>
+                  <a:srgbClr val="222A30"/>
+                </a:solidFill>
+                <a:latin typeface="Arial"/>
+                <a:ea typeface="Microsoft JhengHei"/>
+              </a:rPr>
+              <a:t>② 不永久封鎖:時間到自動探測一次</a:t>
+            </a:r>
+          </a:p>
+          <a:p>
+            <a:pPr>
+              <a:spcAft>
+                <a:spcPts val="300"/>
+              </a:spcAft>
+            </a:pPr>
+            <a:r>
+              <a:rPr sz="800" b="0">
+                <a:solidFill>
+                  <a:srgbClr val="222A30"/>
+                </a:solidFill>
+                <a:latin typeface="Arial"/>
+                <a:ea typeface="Microsoft JhengHei"/>
+              </a:rPr>
+              <a:t>③ 探測又失敗就重新封鎖,間隔加倍(最多 4 倍)</a:t>
+            </a:r>
+          </a:p>
+          <a:p>
+            <a:pPr>
+              <a:spcAft>
+                <a:spcPts val="300"/>
+              </a:spcAft>
+            </a:pPr>
+            <a:r>
+              <a:rPr sz="800" b="0">
+                <a:solidFill>
+                  <a:srgbClr val="222A30"/>
+                </a:solidFill>
+                <a:latin typeface="Arial"/>
+                <a:ea typeface="Microsoft JhengHei"/>
+              </a:rPr>
+              <a:t>④ 要「乾淨且真的有流量」才判定恢復</a:t>
             </a:r>
           </a:p>
           <a:p>
@@ -14708,6 +14987,69 @@
                 <a:ea typeface="Microsoft JhengHei"/>
               </a:rPr>
               <a:t>倍增鏈 300→600→1200 封頂 → 19:18:36 RECOVERED(流量背書)</a:t>
+            </a:r>
+          </a:p>
+        </p:txBody>
+      </p:sp>
+      <p:sp>
+        <p:nvSpPr>
+          <p:cNvPr id="7" name="SimInjection"/>
+          <p:cNvSpPr/>
+          <p:nvPr/>
+        </p:nvSpPr>
+        <p:spPr>
+          <a:xfrm>
+            <a:off x="320040" y="4025000"/>
+            <a:ext cx="5577840" cy="800000"/>
+          </a:xfrm>
+          <a:prstGeom prst="roundRect">
+            <a:avLst/>
+          </a:prstGeom>
+          <a:solidFill>
+            <a:srgbClr val="44546A"/>
+          </a:solidFill>
+          <a:ln w="12700">
+            <a:solidFill>
+              <a:srgbClr val="1CADE4"/>
+            </a:solidFill>
+          </a:ln>
+          <a:effectLst/>
+        </p:spPr>
+        <p:txBody>
+          <a:bodyPr rtlCol="0" anchor="ctr" wrap="square" tIns="45720" bIns="45720"/>
+          <a:lstStyle/>
+          <a:p>
+            <a:pPr algn="ctr">
+              <a:spcAft>
+                <a:spcPts val="200"/>
+              </a:spcAft>
+            </a:pPr>
+            <a:r>
+              <a:rPr sz="1000" b="1">
+                <a:solidFill>
+                  <a:srgbClr val="FFD966"/>
+                </a:solidFill>
+                <a:latin typeface="Arial"/>
+                <a:ea typeface="Microsoft JhengHei"/>
+              </a:rPr>
+              <a:t>sim 端怎麼把這個病做出來</a:t>
+            </a:r>
+          </a:p>
+          <a:p>
+            <a:pPr>
+              <a:spcAft>
+                <a:spcPts val="200"/>
+              </a:spcAft>
+            </a:pPr>
+            <a:r>
+              <a:rPr sz="850" b="0">
+                <a:solidFill>
+                  <a:srgbClr val="FFFFFF"/>
+                </a:solidFill>
+                <a:latin typeface="Arial"/>
+                <a:ea typeface="Microsoft JhengHei"/>
+              </a:rPr>
+              <a:t>Random Access 壞掉:檔案熱開關 tmp/ho_force_fail.txt 寫入「n30_c0,RandomAccessProblem」→ executor 對該 target 的每次換手都在「執行階段」回 RA 失敗(UE 到得了、接不進)。寫檔即生效,免重啟、不打斷 L4 計時。</a:t>
             </a:r>
           </a:p>
         </p:txBody>
@@ -15170,18 +15512,52 @@
           <a:p>
             <a:pPr>
               <a:spcAft>
-                <a:spcPts val="200"/>
+                <a:spcPts val="300"/>
               </a:spcAft>
             </a:pPr>
             <a:r>
-              <a:rPr sz="900" b="0">
+              <a:rPr sz="800" b="0">
                 <a:solidFill>
                   <a:srgbClr val="222A30"/>
                 </a:solidFill>
                 <a:latin typeface="Arial"/>
                 <a:ea typeface="Microsoft JhengHei"/>
               </a:rPr>
-              <a:t>逐 PCI REPORTCGI(帶外來 arfcn)→ ADD;frequencyRelations 由 gNB 自動長出</a:t>
+              <a:t>① 先確認這個頻點不在本 cell 已知的頻率清單裡</a:t>
+            </a:r>
+          </a:p>
+          <a:p>
+            <a:pPr>
+              <a:spcAft>
+                <a:spcPts val="300"/>
+              </a:spcAft>
+            </a:pPr>
+            <a:r>
+              <a:rPr sz="800" b="0">
+                <a:solidFill>
+                  <a:srgbClr val="222A30"/>
+                </a:solidFill>
+                <a:latin typeface="Arial"/>
+                <a:ea typeface="Microsoft JhengHei"/>
+              </a:rPr>
+              <a:t>② 逐個 PCI 讀 CGI(帶上外來頻點)→ 送 ADD</a:t>
+            </a:r>
+          </a:p>
+          <a:p>
+            <a:pPr>
+              <a:spcAft>
+                <a:spcPts val="300"/>
+              </a:spcAft>
+            </a:pPr>
+            <a:r>
+              <a:rPr sz="800" b="0">
+                <a:solidFill>
+                  <a:srgbClr val="222A30"/>
+                </a:solidFill>
+                <a:latin typeface="Arial"/>
+                <a:ea typeface="Microsoft JhengHei"/>
+              </a:rPr>
+              <a:t>③ 頻率層關係由 gNB 自己長出來,xApp 不用另外建</a:t>
             </a:r>
           </a:p>
           <a:p>
@@ -15288,6 +15664,69 @@
                 <a:ea typeface="Microsoft JhengHei"/>
               </a:rPr>
               <a:t>q8_v1..5(空表 bug 由真實 fixture 抓出)</a:t>
+            </a:r>
+          </a:p>
+        </p:txBody>
+      </p:sp>
+      <p:sp>
+        <p:nvSpPr>
+          <p:cNvPr id="7" name="SimInjection"/>
+          <p:cNvSpPr/>
+          <p:nvPr/>
+        </p:nvSpPr>
+        <p:spPr>
+          <a:xfrm>
+            <a:off x="320040" y="4025000"/>
+            <a:ext cx="5577840" cy="800000"/>
+          </a:xfrm>
+          <a:prstGeom prst="roundRect">
+            <a:avLst/>
+          </a:prstGeom>
+          <a:solidFill>
+            <a:srgbClr val="44546A"/>
+          </a:solidFill>
+          <a:ln w="12700">
+            <a:solidFill>
+              <a:srgbClr val="1CADE4"/>
+            </a:solidFill>
+          </a:ln>
+          <a:effectLst/>
+        </p:spPr>
+        <p:txBody>
+          <a:bodyPr rtlCol="0" anchor="ctr" wrap="square" tIns="45720" bIns="45720"/>
+          <a:lstStyle/>
+          <a:p>
+            <a:pPr algn="ctr">
+              <a:spcAft>
+                <a:spcPts val="200"/>
+              </a:spcAft>
+            </a:pPr>
+            <a:r>
+              <a:rPr sz="1000" b="1">
+                <a:solidFill>
+                  <a:srgbClr val="FFD966"/>
+                </a:solidFill>
+                <a:latin typeface="Arial"/>
+                <a:ea typeface="Microsoft JhengHei"/>
+              </a:rPr>
+              <a:t>sim 端怎麼把這個病做出來</a:t>
+            </a:r>
+          </a:p>
+          <a:p>
+            <a:pPr>
+              <a:spcAft>
+                <a:spcPts val="200"/>
+              </a:spcAft>
+            </a:pPr>
+            <a:r>
+              <a:rPr sz="850" b="0">
+                <a:solidFill>
+                  <a:srgbClr val="FFFFFF"/>
+                </a:solidFill>
+                <a:latin typeface="Arial"/>
+                <a:ea typeface="Microsoft JhengHei"/>
+              </a:rPr>
+              <a:t>砍掉 3.5GHz→2.1GHz 整層關係(3 條),2.1G 的 cell 照常存在也量得到;通道計算的干擾只算同頻 —— 形成「看得到卻換不過去」的缺層。</a:t>
             </a:r>
           </a:p>
         </p:txBody>
@@ -15750,18 +16189,69 @@
           <a:p>
             <a:pPr>
               <a:spcAft>
-                <a:spcPts val="200"/>
+                <a:spcPts val="300"/>
               </a:spcAft>
             </a:pPr>
             <a:r>
-              <a:rPr sz="900" b="0">
+              <a:rPr sz="800" b="0">
                 <a:solidFill>
                   <a:srgbClr val="222A30"/>
                 </a:solidFill>
                 <a:latin typeface="Arial"/>
                 <a:ea typeface="Microsoft JhengHei"/>
               </a:rPr>
-              <a:t>挑最冷 REMOVE(至多 3 候選)→ 騰位 ADD;全拒 → SMO;discovery 分支見滿載自我抑制讓路</a:t>
+              <a:t>① 挑最冷的條目(沒量測也沒換手)最多 3 條,送 REMOVE 騰位</a:t>
+            </a:r>
+          </a:p>
+          <a:p>
+            <a:pPr>
+              <a:spcAft>
+                <a:spcPts val="300"/>
+              </a:spcAft>
+            </a:pPr>
+            <a:r>
+              <a:rPr sz="800" b="0">
+                <a:solidFill>
+                  <a:srgbClr val="222A30"/>
+                </a:solidFill>
+                <a:latin typeface="Arial"/>
+                <a:ea typeface="Microsoft JhengHei"/>
+              </a:rPr>
+              <a:t>② 騰出空間後再送 ADD 建新關係</a:t>
+            </a:r>
+          </a:p>
+          <a:p>
+            <a:pPr>
+              <a:spcAft>
+                <a:spcPts val="300"/>
+              </a:spcAft>
+            </a:pPr>
+            <a:r>
+              <a:rPr sz="800" b="0">
+                <a:solidFill>
+                  <a:srgbClr val="222A30"/>
+                </a:solidFill>
+                <a:latin typeface="Arial"/>
+                <a:ea typeface="Microsoft JhengHei"/>
+              </a:rPr>
+              <a:t>③ 若全被拒(受保護條目)→ 停手送 SMO,不硬刪</a:t>
+            </a:r>
+          </a:p>
+          <a:p>
+            <a:pPr>
+              <a:spcAft>
+                <a:spcPts val="300"/>
+              </a:spcAft>
+            </a:pPr>
+            <a:r>
+              <a:rPr sz="800" b="0">
+                <a:solidFill>
+                  <a:srgbClr val="222A30"/>
+                </a:solidFill>
+                <a:latin typeface="Arial"/>
+                <a:ea typeface="Microsoft JhengHei"/>
+              </a:rPr>
+              <a:t>④ 這段期間其他分支看到滿載會自動讓路</a:t>
             </a:r>
           </a:p>
           <a:p>
@@ -15868,6 +16358,69 @@
                 <a:ea typeface="Microsoft JhengHei"/>
               </a:rPr>
               <a:t>q9_v1..4(v10 遷移曾漏數的第 6 支重工)</a:t>
+            </a:r>
+          </a:p>
+        </p:txBody>
+      </p:sp>
+      <p:sp>
+        <p:nvSpPr>
+          <p:cNvPr id="7" name="SimInjection"/>
+          <p:cNvSpPr/>
+          <p:nvPr/>
+        </p:nvSpPr>
+        <p:spPr>
+          <a:xfrm>
+            <a:off x="320040" y="4025000"/>
+            <a:ext cx="5577840" cy="800000"/>
+          </a:xfrm>
+          <a:prstGeom prst="roundRect">
+            <a:avLst/>
+          </a:prstGeom>
+          <a:solidFill>
+            <a:srgbClr val="44546A"/>
+          </a:solidFill>
+          <a:ln w="12700">
+            <a:solidFill>
+              <a:srgbClr val="1CADE4"/>
+            </a:solidFill>
+          </a:ln>
+          <a:effectLst/>
+        </p:spPr>
+        <p:txBody>
+          <a:bodyPr rtlCol="0" anchor="ctr" wrap="square" tIns="45720" bIns="45720"/>
+          <a:lstStyle/>
+          <a:p>
+            <a:pPr algn="ctr">
+              <a:spcAft>
+                <a:spcPts val="200"/>
+              </a:spcAft>
+            </a:pPr>
+            <a:r>
+              <a:rPr sz="1000" b="1">
+                <a:solidFill>
+                  <a:srgbClr val="FFD966"/>
+                </a:solidFill>
+                <a:latin typeface="Arial"/>
+                <a:ea typeface="Microsoft JhengHei"/>
+              </a:rPr>
+              <a:t>sim 端怎麼把這個病做出來</a:t>
+            </a:r>
+          </a:p>
+          <a:p>
+            <a:pPr>
+              <a:spcAft>
+                <a:spcPts val="200"/>
+              </a:spcAft>
+            </a:pPr>
+            <a:r>
+              <a:rPr sz="850" b="0">
+                <a:solidFill>
+                  <a:srgbClr val="FFFFFF"/>
+                </a:solidFill>
+                <a:latin typeface="Arial"/>
+                <a:ea typeface="Microsoft JhengHei"/>
+              </a:rPr>
+              <a:t>灌入合成關係把三顆 cell 的 NRT 填到 used==limit;其中刻意放一條零活動的 x24(該被修剪)與一條 noRemove 的 x25(修剪必被拒),讓 try-prune 兩種結局都驗得到。</a:t>
             </a:r>
           </a:p>
         </p:txBody>
@@ -16330,18 +16883,52 @@
           <a:p>
             <a:pPr>
               <a:spcAft>
-                <a:spcPts val="200"/>
+                <a:spcPts val="300"/>
               </a:spcAft>
             </a:pPr>
             <a:r>
-              <a:rPr sz="900" b="0">
+              <a:rPr sz="800" b="0">
                 <a:solidFill>
                   <a:srgbClr val="222A30"/>
                 </a:solidFill>
                 <a:latin typeface="Arial"/>
                 <a:ea typeface="Microsoft JhengHei"/>
               </a:rPr>
-              <a:t>verify-first(storedPci 仍對→不修)→ REMOVE(stale-pci)+ADD 原子 → 失敗率消退</a:t>
+              <a:t>① 先驗證:表裡記的 PCI 若其實還對就不動(避免誤修)</a:t>
+            </a:r>
+          </a:p>
+          <a:p>
+            <a:pPr>
+              <a:spcAft>
+                <a:spcPts val="300"/>
+              </a:spcAft>
+            </a:pPr>
+            <a:r>
+              <a:rPr sz="800" b="0">
+                <a:solidFill>
+                  <a:srgbClr val="222A30"/>
+                </a:solidFill>
+                <a:latin typeface="Arial"/>
+                <a:ea typeface="Microsoft JhengHei"/>
+              </a:rPr>
+              <a:t>② 確認過期 → 刪舊條目 + 建正確的新條目,同一步完成不留空窗</a:t>
+            </a:r>
+          </a:p>
+          <a:p>
+            <a:pPr>
+              <a:spcAft>
+                <a:spcPts val="300"/>
+              </a:spcAft>
+            </a:pPr>
+            <a:r>
+              <a:rPr sz="800" b="0">
+                <a:solidFill>
+                  <a:srgbClr val="222A30"/>
+                </a:solidFill>
+                <a:latin typeface="Arial"/>
+                <a:ea typeface="Microsoft JhengHei"/>
+              </a:rPr>
+              <a:t>③ 看換手失敗率消退確認修好</a:t>
             </a:r>
           </a:p>
           <a:p>
@@ -16448,6 +17035,69 @@
                 <a:ea typeface="Microsoft JhengHei"/>
               </a:rPr>
               <a:t>03:14:56 同秒重指 → pci=233、CNA 歸零、SUCC 恢復</a:t>
+            </a:r>
+          </a:p>
+        </p:txBody>
+      </p:sp>
+      <p:sp>
+        <p:nvSpPr>
+          <p:cNvPr id="7" name="SimInjection"/>
+          <p:cNvSpPr/>
+          <p:nvPr/>
+        </p:nvSpPr>
+        <p:spPr>
+          <a:xfrm>
+            <a:off x="320040" y="4025000"/>
+            <a:ext cx="5577840" cy="800000"/>
+          </a:xfrm>
+          <a:prstGeom prst="roundRect">
+            <a:avLst/>
+          </a:prstGeom>
+          <a:solidFill>
+            <a:srgbClr val="44546A"/>
+          </a:solidFill>
+          <a:ln w="12700">
+            <a:solidFill>
+              <a:srgbClr val="1CADE4"/>
+            </a:solidFill>
+          </a:ln>
+          <a:effectLst/>
+        </p:spPr>
+        <p:txBody>
+          <a:bodyPr rtlCol="0" anchor="ctr" wrap="square" tIns="45720" bIns="45720"/>
+          <a:lstStyle/>
+          <a:p>
+            <a:pPr algn="ctr">
+              <a:spcAft>
+                <a:spcPts val="200"/>
+              </a:spcAft>
+            </a:pPr>
+            <a:r>
+              <a:rPr sz="1000" b="1">
+                <a:solidFill>
+                  <a:srgbClr val="FFD966"/>
+                </a:solidFill>
+                <a:latin typeface="Arial"/>
+                <a:ea typeface="Microsoft JhengHei"/>
+              </a:rPr>
+              <a:t>sim 端怎麼把這個病做出來</a:t>
+            </a:r>
+          </a:p>
+          <a:p>
+            <a:pPr>
+              <a:spcAft>
+                <a:spcPts val="200"/>
+              </a:spcAft>
+            </a:pPr>
+            <a:r>
+              <a:rPr sz="850" b="0">
+                <a:solidFill>
+                  <a:srgbClr val="FFFFFF"/>
+                </a:solidFill>
+                <a:latin typeface="Arial"/>
+                <a:ea typeface="Microsoft JhengHei"/>
+              </a:rPr>
+              <a:t>Neighbor 還在,但表裡的資訊過期:只把條目的 target_pci 改成舊值 205,而 cell 實際 pci 已是 233。executor 換手前比對不符 → 回 CellNotAvailable;UE 搬回 s15 讓 A3 反覆去撞。</a:t>
             </a:r>
           </a:p>
         </p:txBody>
@@ -16910,18 +17560,52 @@
           <a:p>
             <a:pPr>
               <a:spcAft>
-                <a:spcPts val="200"/>
+                <a:spcPts val="300"/>
               </a:spcAft>
             </a:pPr>
             <a:r>
-              <a:rPr sz="900" b="0">
+              <a:rPr sz="800" b="0">
                 <a:solidFill>
                   <a:srgbClr val="222A30"/>
                 </a:solidFill>
                 <a:latin typeface="Arial"/>
                 <a:ea typeface="Microsoft JhengHei"/>
               </a:rPr>
-              <a:t>REMOVE(aging);被拒 = SMO + 入不重試帳本絕不重試(重啟由事件回填,不失憶)</a:t>
+              <a:t>① 量測與換手嘗試「同時為零」且持續滿窗,才送 REMOVE 回收</a:t>
+            </a:r>
+          </a:p>
+          <a:p>
+            <a:pPr>
+              <a:spcAft>
+                <a:spcPts val="300"/>
+              </a:spcAft>
+            </a:pPr>
+            <a:r>
+              <a:rPr sz="800" b="0">
+                <a:solidFill>
+                  <a:srgbClr val="222A30"/>
+                </a:solidFill>
+                <a:latin typeface="Arial"/>
+                <a:ea typeface="Microsoft JhengHei"/>
+              </a:rPr>
+              <a:t>② 被拒(受保護)= 記進「不再重試」帳本 + 送 SMO,絕不重複下手</a:t>
+            </a:r>
+          </a:p>
+          <a:p>
+            <a:pPr>
+              <a:spcAft>
+                <a:spcPts val="300"/>
+              </a:spcAft>
+            </a:pPr>
+            <a:r>
+              <a:rPr sz="800" b="0">
+                <a:solidFill>
+                  <a:srgbClr val="222A30"/>
+                </a:solidFill>
+                <a:latin typeface="Arial"/>
+                <a:ea typeface="Microsoft JhengHei"/>
+              </a:rPr>
+              <a:t>③ 重啟後靠事件流把帳本補回來,不會忘記自己做過什麼</a:t>
             </a:r>
           </a:p>
           <a:p>
@@ -17028,6 +17712,69 @@
                 <a:ea typeface="Microsoft JhengHei"/>
               </a:rPr>
               <a:t>四型矩陣:乾淨 REMOVED / 拒後零重發 / 單零不誤刪 / 活躍不碰</a:t>
+            </a:r>
+          </a:p>
+        </p:txBody>
+      </p:sp>
+      <p:sp>
+        <p:nvSpPr>
+          <p:cNvPr id="7" name="SimInjection"/>
+          <p:cNvSpPr/>
+          <p:nvPr/>
+        </p:nvSpPr>
+        <p:spPr>
+          <a:xfrm>
+            <a:off x="320040" y="4025000"/>
+            <a:ext cx="5577840" cy="800000"/>
+          </a:xfrm>
+          <a:prstGeom prst="roundRect">
+            <a:avLst/>
+          </a:prstGeom>
+          <a:solidFill>
+            <a:srgbClr val="44546A"/>
+          </a:solidFill>
+          <a:ln w="12700">
+            <a:solidFill>
+              <a:srgbClr val="1CADE4"/>
+            </a:solidFill>
+          </a:ln>
+          <a:effectLst/>
+        </p:spPr>
+        <p:txBody>
+          <a:bodyPr rtlCol="0" anchor="ctr" wrap="square" tIns="45720" bIns="45720"/>
+          <a:lstStyle/>
+          <a:p>
+            <a:pPr algn="ctr">
+              <a:spcAft>
+                <a:spcPts val="200"/>
+              </a:spcAft>
+            </a:pPr>
+            <a:r>
+              <a:rPr sz="1000" b="1">
+                <a:solidFill>
+                  <a:srgbClr val="FFD966"/>
+                </a:solidFill>
+                <a:latin typeface="Arial"/>
+                <a:ea typeface="Microsoft JhengHei"/>
+              </a:rPr>
+              <a:t>sim 端怎麼把這個病做出來</a:t>
+            </a:r>
+          </a:p>
+          <a:p>
+            <a:pPr>
+              <a:spcAft>
+                <a:spcPts val="200"/>
+              </a:spcAft>
+            </a:pPr>
+            <a:r>
+              <a:rPr sz="850" b="0">
+                <a:solidFill>
+                  <a:srgbClr val="FFFFFF"/>
+                </a:solidFill>
+                <a:latin typeface="Arial"/>
+                <a:ea typeface="Microsoft JhengHei"/>
+              </a:rPr>
+              <a:t>建 ghost 條目 main→dead_c0(目標 cell 根本不存在、無保護)與 main→old_c0(protected,驗拒絕路徑);另留 main→tmp_c0 當單零對照(有量測、無換手,不得誤刪)。</a:t>
             </a:r>
           </a:p>
         </p:txBody>
@@ -17490,18 +18237,52 @@
           <a:p>
             <a:pPr>
               <a:spcAft>
-                <a:spcPts val="200"/>
+                <a:spcPts val="300"/>
               </a:spcAft>
             </a:pPr>
             <a:r>
-              <a:rPr sz="900" b="0">
+              <a:rPr sz="800" b="0">
                 <a:solidFill>
                   <a:srgbClr val="222A30"/>
                 </a:solidFill>
                 <a:latin typeface="Arial"/>
                 <a:ea typeface="Microsoft JhengHei"/>
               </a:rPr>
-              <a:t>無據 → 成對 FLAG_CLEAR 修復 + 告警 + 行為確認;正當 → 已檢視、不動、不入 /alarms</a:t>
+              <a:t>① 旗標在 E2 看不到,只能從行為推論是不是被無故封鎖</a:t>
+            </a:r>
+          </a:p>
+          <a:p>
+            <a:pPr>
+              <a:spcAft>
+                <a:spcPts val="300"/>
+              </a:spcAft>
+            </a:pPr>
+            <a:r>
+              <a:rPr sz="800" b="0">
+                <a:solidFill>
+                  <a:srgbClr val="222A30"/>
+                </a:solidFill>
+                <a:latin typeface="Arial"/>
+                <a:ea typeface="Microsoft JhengHei"/>
+              </a:rPr>
+              <a:t>② 判定「無據」→ 成對解除 + 告警 + 確認 UE 真的開始走</a:t>
+            </a:r>
+          </a:p>
+          <a:p>
+            <a:pPr>
+              <a:spcAft>
+                <a:spcPts val="300"/>
+              </a:spcAft>
+            </a:pPr>
+            <a:r>
+              <a:rPr sz="800" b="0">
+                <a:solidFill>
+                  <a:srgbClr val="222A30"/>
+                </a:solidFill>
+                <a:latin typeface="Arial"/>
+                <a:ea typeface="Microsoft JhengHei"/>
+              </a:rPr>
+              <a:t>③ 判定「正當」(有失敗歷史)→ 看過就好,不動、也不告警</a:t>
             </a:r>
           </a:p>
           <a:p>
@@ -17607,7 +18388,70 @@
                 <a:latin typeface="Arial"/>
                 <a:ea typeface="Microsoft JhengHei"/>
               </a:rPr>
-              <a:t>live:正當封鎖不碰(cum 有史)✅;⚠ sim hoValidated 恆 false → 無據判定失真,待修後重驗</a:t>
+              <a:t>live:正當封鎖不碰(cum 有史)✅;sim hoValidated 已修並回填(08/26),假陽性成因消失,待 RIC 補「新生關係寬限」後重驗</a:t>
+            </a:r>
+          </a:p>
+        </p:txBody>
+      </p:sp>
+      <p:sp>
+        <p:nvSpPr>
+          <p:cNvPr id="7" name="SimInjection"/>
+          <p:cNvSpPr/>
+          <p:nvPr/>
+        </p:nvSpPr>
+        <p:spPr>
+          <a:xfrm>
+            <a:off x="320040" y="4025000"/>
+            <a:ext cx="5577840" cy="800000"/>
+          </a:xfrm>
+          <a:prstGeom prst="roundRect">
+            <a:avLst/>
+          </a:prstGeom>
+          <a:solidFill>
+            <a:srgbClr val="44546A"/>
+          </a:solidFill>
+          <a:ln w="12700">
+            <a:solidFill>
+              <a:srgbClr val="1CADE4"/>
+            </a:solidFill>
+          </a:ln>
+          <a:effectLst/>
+        </p:spPr>
+        <p:txBody>
+          <a:bodyPr rtlCol="0" anchor="ctr" wrap="square" tIns="45720" bIns="45720"/>
+          <a:lstStyle/>
+          <a:p>
+            <a:pPr algn="ctr">
+              <a:spcAft>
+                <a:spcPts val="200"/>
+              </a:spcAft>
+            </a:pPr>
+            <a:r>
+              <a:rPr sz="1000" b="1">
+                <a:solidFill>
+                  <a:srgbClr val="FFD966"/>
+                </a:solidFill>
+                <a:latin typeface="Arial"/>
+                <a:ea typeface="Microsoft JhengHei"/>
+              </a:rPr>
+              <a:t>sim 端怎麼把這個病做出來</a:t>
+            </a:r>
+          </a:p>
+          <a:p>
+            <a:pPr>
+              <a:spcAft>
+                <a:spcPts val="200"/>
+              </a:spcAft>
+            </a:pPr>
+            <a:r>
+              <a:rPr sz="850" b="0">
+                <a:solidFill>
+                  <a:srgbClr val="FFFFFF"/>
+                </a:solidFill>
+                <a:latin typeface="Arial"/>
+                <a:ea typeface="Microsoft JhengHei"/>
+              </a:rPr>
+              <a:t>兩條關係給一模一樣的旗標(hoBlocklist+xnBlocklist),差別只造在行為訊號:n80 注入 40 筆歷史 RA 失敗 + hoValidated=true(正當);d02 零失敗史 + hoValidated=false(無據)。</a:t>
             </a:r>
           </a:p>
         </p:txBody>
@@ -20349,18 +21193,69 @@
           <a:p>
             <a:pPr>
               <a:spcAft>
-                <a:spcPts val="200"/>
+                <a:spcPts val="300"/>
               </a:spcAft>
             </a:pPr>
             <a:r>
-              <a:rPr sz="900" b="0">
+              <a:rPr sz="800" b="0">
                 <a:solidFill>
                   <a:srgbClr val="222A30"/>
                 </a:solidFill>
                 <a:latin typeface="Arial"/>
                 <a:ea typeface="Microsoft JhengHei"/>
               </a:rPr>
-              <a:t>REPORTCGI 解析(unique)→ anr-add(單向)→ confirm(推播/快照)→ UE 開始走新關係</a:t>
+              <a:t>① 請基地台叫 UE 去讀目標的全域識別(CGI)——「REPORTCGI」,解析結果唯一才算數</a:t>
+            </a:r>
+          </a:p>
+          <a:p>
+            <a:pPr>
+              <a:spcAft>
+                <a:spcPts val="300"/>
+              </a:spcAft>
+            </a:pPr>
+            <a:r>
+              <a:rPr sz="800" b="0">
+                <a:solidFill>
+                  <a:srgbClr val="222A30"/>
+                </a:solidFill>
+                <a:latin typeface="Arial"/>
+                <a:ea typeface="Microsoft JhengHei"/>
+              </a:rPr>
+              <a:t>② 送 ADD 請 gNB 建立這條鄰區關係(只建單向;反向由對方 gNB 自己建)</a:t>
+            </a:r>
+          </a:p>
+          <a:p>
+            <a:pPr>
+              <a:spcAft>
+                <a:spcPts val="300"/>
+              </a:spcAft>
+            </a:pPr>
+            <a:r>
+              <a:rPr sz="800" b="0">
+                <a:solidFill>
+                  <a:srgbClr val="222A30"/>
+                </a:solidFill>
+                <a:latin typeface="Arial"/>
+                <a:ea typeface="Microsoft JhengHei"/>
+              </a:rPr>
+              <a:t>③ 等 NRT 回讀確認真的寫進去了(推播或下一張快照)</a:t>
+            </a:r>
+          </a:p>
+          <a:p>
+            <a:pPr>
+              <a:spcAft>
+                <a:spcPts val="300"/>
+              </a:spcAft>
+            </a:pPr>
+            <a:r>
+              <a:rPr sz="800" b="0">
+                <a:solidFill>
+                  <a:srgbClr val="222A30"/>
+                </a:solidFill>
+                <a:latin typeface="Arial"/>
+                <a:ea typeface="Microsoft JhengHei"/>
+              </a:rPr>
+              <a:t>④ 看 UE 開始走新關係、掉線重建歸零 = 真的修好</a:t>
             </a:r>
           </a:p>
           <a:p>
@@ -20467,6 +21362,69 @@
                 <a:ea typeface="Microsoft JhengHei"/>
               </a:rPr>
               <a:t>乾淨重跑:03:24:36 ADD → A3 SUCC 4/0 → RLF 歸零</a:t>
+            </a:r>
+          </a:p>
+        </p:txBody>
+      </p:sp>
+      <p:sp>
+        <p:nvSpPr>
+          <p:cNvPr id="8" name="SimInjection"/>
+          <p:cNvSpPr/>
+          <p:nvPr/>
+        </p:nvSpPr>
+        <p:spPr>
+          <a:xfrm>
+            <a:off x="320040" y="4025000"/>
+            <a:ext cx="5577840" cy="800000"/>
+          </a:xfrm>
+          <a:prstGeom prst="roundRect">
+            <a:avLst/>
+          </a:prstGeom>
+          <a:solidFill>
+            <a:srgbClr val="44546A"/>
+          </a:solidFill>
+          <a:ln w="12700">
+            <a:solidFill>
+              <a:srgbClr val="1CADE4"/>
+            </a:solidFill>
+          </a:ln>
+          <a:effectLst/>
+        </p:spPr>
+        <p:txBody>
+          <a:bodyPr rtlCol="0" anchor="ctr" wrap="square" tIns="45720" bIns="45720"/>
+          <a:lstStyle/>
+          <a:p>
+            <a:pPr algn="ctr">
+              <a:spcAft>
+                <a:spcPts val="200"/>
+              </a:spcAft>
+            </a:pPr>
+            <a:r>
+              <a:rPr sz="1000" b="1">
+                <a:solidFill>
+                  <a:srgbClr val="FFD966"/>
+                </a:solidFill>
+                <a:latin typeface="Arial"/>
+                <a:ea typeface="Microsoft JhengHei"/>
+              </a:rPr>
+              <a:t>sim 端怎麼把這個病做出來</a:t>
+            </a:r>
+          </a:p>
+          <a:p>
+            <a:pPr>
+              <a:spcAft>
+                <a:spcPts val="200"/>
+              </a:spcAft>
+            </a:pPr>
+            <a:r>
+              <a:rPr sz="850" b="0">
+                <a:solidFill>
+                  <a:srgbClr val="FFFFFF"/>
+                </a:solidFill>
+                <a:latin typeface="Arial"/>
+                <a:ea typeface="Microsoft JhengHei"/>
+              </a:rPr>
+              <a:t>刪掉 NRT 裡 src→nbr 那一條(_cut)。sim 的 A3 有 NRT 閘(ANR_REQUIRE_NRT):表上沒有就不准換手 → UE 一路撐到 RLF → 掉線後重建到對向 cell,回流統計才長得出來。</a:t>
             </a:r>
           </a:p>
         </p:txBody>
@@ -21019,18 +21977,52 @@
           <a:p>
             <a:pPr>
               <a:spcAft>
-                <a:spcPts val="200"/>
+                <a:spcPts val="300"/>
               </a:spcAft>
             </a:pPr>
             <a:r>
-              <a:rPr sz="900" b="0">
+              <a:rPr sz="800" b="0">
                 <a:solidFill>
                   <a:srgbClr val="222A30"/>
                 </a:solidFill>
                 <a:latin typeface="Arial"/>
                 <a:ea typeface="Microsoft JhengHei"/>
               </a:rPr>
-              <a:t>REPORTCGI → anr-add;anrIntraEnabled=false 時改「偵測+拒寫+SMO」</a:t>
+              <a:t>① 這題不必等 UE 掉線 —— 量測就看得出「該換卻沒有關係」</a:t>
+            </a:r>
+          </a:p>
+          <a:p>
+            <a:pPr>
+              <a:spcAft>
+                <a:spcPts val="300"/>
+              </a:spcAft>
+            </a:pPr>
+            <a:r>
+              <a:rPr sz="800" b="0">
+                <a:solidFill>
+                  <a:srgbClr val="222A30"/>
+                </a:solidFill>
+                <a:latin typeface="Arial"/>
+                <a:ea typeface="Microsoft JhengHei"/>
+              </a:rPr>
+              <a:t>② 讀出目標 CGI → 送 ADD 建關係</a:t>
+            </a:r>
+          </a:p>
+          <a:p>
+            <a:pPr>
+              <a:spcAft>
+                <a:spcPts val="300"/>
+              </a:spcAft>
+            </a:pPr>
+            <a:r>
+              <a:rPr sz="800" b="0">
+                <a:solidFill>
+                  <a:srgbClr val="222A30"/>
+                </a:solidFill>
+                <a:latin typeface="Arial"/>
+                <a:ea typeface="Microsoft JhengHei"/>
+              </a:rPr>
+              <a:t>③ 若該基地台把 ANR 自動建立關掉了:只偵測、不寫入,改送 SMO 請管理面處理</a:t>
             </a:r>
           </a:p>
           <a:p>
@@ -21137,6 +22129,69 @@
                 <a:ea typeface="Microsoft JhengHei"/>
               </a:rPr>
               <a:t>q2_v1..5(6.1dB 邊界正反)+ 抽驗中 live ADD</a:t>
+            </a:r>
+          </a:p>
+        </p:txBody>
+      </p:sp>
+      <p:sp>
+        <p:nvSpPr>
+          <p:cNvPr id="8" name="SimInjection"/>
+          <p:cNvSpPr/>
+          <p:nvPr/>
+        </p:nvSpPr>
+        <p:spPr>
+          <a:xfrm>
+            <a:off x="320040" y="4025000"/>
+            <a:ext cx="5577840" cy="800000"/>
+          </a:xfrm>
+          <a:prstGeom prst="roundRect">
+            <a:avLst/>
+          </a:prstGeom>
+          <a:solidFill>
+            <a:srgbClr val="44546A"/>
+          </a:solidFill>
+          <a:ln w="12700">
+            <a:solidFill>
+              <a:srgbClr val="1CADE4"/>
+            </a:solidFill>
+          </a:ln>
+          <a:effectLst/>
+        </p:spPr>
+        <p:txBody>
+          <a:bodyPr rtlCol="0" anchor="ctr" wrap="square" tIns="45720" bIns="45720"/>
+          <a:lstStyle/>
+          <a:p>
+            <a:pPr algn="ctr">
+              <a:spcAft>
+                <a:spcPts val="200"/>
+              </a:spcAft>
+            </a:pPr>
+            <a:r>
+              <a:rPr sz="1000" b="1">
+                <a:solidFill>
+                  <a:srgbClr val="FFD966"/>
+                </a:solidFill>
+                <a:latin typeface="Arial"/>
+                <a:ea typeface="Microsoft JhengHei"/>
+              </a:rPr>
+              <a:t>sim 端怎麼把這個病做出來</a:t>
+            </a:r>
+          </a:p>
+          <a:p>
+            <a:pPr>
+              <a:spcAft>
+                <a:spcPts val="200"/>
+              </a:spcAft>
+            </a:pPr>
+            <a:r>
+              <a:rPr sz="850" b="0">
+                <a:solidFill>
+                  <a:srgbClr val="FFFFFF"/>
+                </a:solidFill>
+                <a:latin typeface="Arial"/>
+                <a:ea typeface="Microsoft JhengHei"/>
+              </a:rPr>
+              <a:t>一樣剪掉 s25→n35 條目,但用 PathSolver 逐點實測把 UE 擺進「鄰區進逼卻不掉線」的窄窗(gap≈0.1dB、SINR≥−2)—— 與第 1 題的差別在 UE 撐得住、不靠 RLF 顯病。</a:t>
             </a:r>
           </a:p>
         </p:txBody>
@@ -23013,18 +24068,52 @@
           <a:p>
             <a:pPr>
               <a:spcAft>
-                <a:spcPts val="200"/>
+                <a:spcPts val="300"/>
               </a:spcAft>
             </a:pPr>
             <a:r>
-              <a:rPr sz="900" b="0">
+              <a:rPr sz="800" b="0">
                 <a:solidFill>
                   <a:srgbClr val="222A30"/>
                 </a:solidFill>
                 <a:latin typeface="Arial"/>
                 <a:ea typeface="Microsoft JhengHei"/>
               </a:rPr>
-              <a:t>REPORTCGI ×3 抽樣一致 → anr-add;容量滿讓 Q9</a:t>
+              <a:t>① 深邊緣本來人就少,不可以因為「量測次數太少」把它駁回</a:t>
+            </a:r>
+          </a:p>
+          <a:p>
+            <a:pPr>
+              <a:spcAft>
+                <a:spcPts val="300"/>
+              </a:spcAft>
+            </a:pPr>
+            <a:r>
+              <a:rPr sz="800" b="0">
+                <a:solidFill>
+                  <a:srgbClr val="222A30"/>
+                </a:solidFill>
+                <a:latin typeface="Arial"/>
+                <a:ea typeface="Microsoft JhengHei"/>
+              </a:rPr>
+              <a:t>② 目標 CGI 連續抽樣 3 次結果一致才採信 → 送 ADD</a:t>
+            </a:r>
+          </a:p>
+          <a:p>
+            <a:pPr>
+              <a:spcAft>
+                <a:spcPts val="300"/>
+              </a:spcAft>
+            </a:pPr>
+            <a:r>
+              <a:rPr sz="800" b="0">
+                <a:solidFill>
+                  <a:srgbClr val="222A30"/>
+                </a:solidFill>
+                <a:latin typeface="Arial"/>
+                <a:ea typeface="Microsoft JhengHei"/>
+              </a:rPr>
+              <a:t>③ 若鄰區表已滿,讓第 9 題的容量修剪先處理</a:t>
             </a:r>
           </a:p>
           <a:p>
@@ -23131,6 +24220,69 @@
                 <a:ea typeface="Microsoft JhengHei"/>
               </a:rPr>
               <a:t>q3_v1..7 離線向量 ✅;live fixture 為「報告門檻 −85」型,深邊緣增益構型待補</a:t>
+            </a:r>
+          </a:p>
+        </p:txBody>
+      </p:sp>
+      <p:sp>
+        <p:nvSpPr>
+          <p:cNvPr id="7" name="SimInjection"/>
+          <p:cNvSpPr/>
+          <p:nvPr/>
+        </p:nvSpPr>
+        <p:spPr>
+          <a:xfrm>
+            <a:off x="320040" y="4025000"/>
+            <a:ext cx="5577840" cy="800000"/>
+          </a:xfrm>
+          <a:prstGeom prst="roundRect">
+            <a:avLst/>
+          </a:prstGeom>
+          <a:solidFill>
+            <a:srgbClr val="44546A"/>
+          </a:solidFill>
+          <a:ln w="12700">
+            <a:solidFill>
+              <a:srgbClr val="1CADE4"/>
+            </a:solidFill>
+          </a:ln>
+          <a:effectLst/>
+        </p:spPr>
+        <p:txBody>
+          <a:bodyPr rtlCol="0" anchor="ctr" wrap="square" tIns="45720" bIns="45720"/>
+          <a:lstStyle/>
+          <a:p>
+            <a:pPr algn="ctr">
+              <a:spcAft>
+                <a:spcPts val="200"/>
+              </a:spcAft>
+            </a:pPr>
+            <a:r>
+              <a:rPr sz="1000" b="1">
+                <a:solidFill>
+                  <a:srgbClr val="FFD966"/>
+                </a:solidFill>
+                <a:latin typeface="Arial"/>
+                <a:ea typeface="Microsoft JhengHei"/>
+              </a:rPr>
+              <a:t>sim 端怎麼把這個病做出來</a:t>
+            </a:r>
+          </a:p>
+          <a:p>
+            <a:pPr>
+              <a:spcAft>
+                <a:spcPts val="200"/>
+              </a:spcAft>
+            </a:pPr>
+            <a:r>
+              <a:rPr sz="850" b="0">
+                <a:solidFill>
+                  <a:srgbClr val="FFFFFF"/>
+                </a:solidFill>
+                <a:latin typeface="Arial"/>
+                <a:ea typeface="Microsoft JhengHei"/>
+              </a:rPr>
+              <a:t>現行:剪掉 s28→n91 + 臨時把量測回報門檻設 −85dBm(TS 38.331 reportConfig)讓樣本變稀疏。⚠ 卷面要的是深邊緣幾何(serving ≤−105、相對增益 ≥10dB);實測 s28 天線凹陷可達 −108.7dBm,場景重佈中。</a:t>
             </a:r>
           </a:p>
         </p:txBody>
@@ -23593,18 +24745,35 @@
           <a:p>
             <a:pPr>
               <a:spcAft>
-                <a:spcPts val="200"/>
+                <a:spcPts val="300"/>
               </a:spcAft>
             </a:pPr>
             <a:r>
-              <a:rPr sz="900" b="0">
+              <a:rPr sz="800" b="0">
                 <a:solidFill>
                   <a:srgbClr val="222A30"/>
                 </a:solidFill>
                 <a:latin typeface="Arial"/>
                 <a:ea typeface="Microsoft JhengHei"/>
               </a:rPr>
-              <a:t>REPORTCGI ×2 一致 ∧ novel(不在既有 targets)→ 單向 ADD</a:t>
+              <a:t>① 先確認這個 (PCI, 頻點) 不在任何既有關係裡 —— 真的是新面孔</a:t>
+            </a:r>
+          </a:p>
+          <a:p>
+            <a:pPr>
+              <a:spcAft>
+                <a:spcPts val="300"/>
+              </a:spcAft>
+            </a:pPr>
+            <a:r>
+              <a:rPr sz="800" b="0">
+                <a:solidFill>
+                  <a:srgbClr val="222A30"/>
+                </a:solidFill>
+                <a:latin typeface="Arial"/>
+                <a:ea typeface="Microsoft JhengHei"/>
+              </a:rPr>
+              <a:t>② 目標 CGI 抽樣 2 次一致 → 送 ADD 建單向關係</a:t>
             </a:r>
           </a:p>
           <a:p>
@@ -23711,6 +24880,69 @@
                 <a:ea typeface="Microsoft JhengHei"/>
               </a:rPr>
               <a:t>q4_v1..4 + 抽驗中 live ADD(RLF-rank 猜來源已退役)</a:t>
+            </a:r>
+          </a:p>
+        </p:txBody>
+      </p:sp>
+      <p:sp>
+        <p:nvSpPr>
+          <p:cNvPr id="7" name="SimInjection"/>
+          <p:cNvSpPr/>
+          <p:nvPr/>
+        </p:nvSpPr>
+        <p:spPr>
+          <a:xfrm>
+            <a:off x="320040" y="4025000"/>
+            <a:ext cx="5577840" cy="800000"/>
+          </a:xfrm>
+          <a:prstGeom prst="roundRect">
+            <a:avLst/>
+          </a:prstGeom>
+          <a:solidFill>
+            <a:srgbClr val="44546A"/>
+          </a:solidFill>
+          <a:ln w="12700">
+            <a:solidFill>
+              <a:srgbClr val="1CADE4"/>
+            </a:solidFill>
+          </a:ln>
+          <a:effectLst/>
+        </p:spPr>
+        <p:txBody>
+          <a:bodyPr rtlCol="0" anchor="ctr" wrap="square" tIns="45720" bIns="45720"/>
+          <a:lstStyle/>
+          <a:p>
+            <a:pPr algn="ctr">
+              <a:spcAft>
+                <a:spcPts val="200"/>
+              </a:spcAft>
+            </a:pPr>
+            <a:r>
+              <a:rPr sz="1000" b="1">
+                <a:solidFill>
+                  <a:srgbClr val="FFD966"/>
+                </a:solidFill>
+                <a:latin typeface="Arial"/>
+                <a:ea typeface="Microsoft JhengHei"/>
+              </a:rPr>
+              <a:t>sim 端怎麼把這個病做出來</a:t>
+            </a:r>
+          </a:p>
+          <a:p>
+            <a:pPr>
+              <a:spcAft>
+                <a:spcPts val="200"/>
+              </a:spcAft>
+            </a:pPr>
+            <a:r>
+              <a:rPr sz="850" b="0">
+                <a:solidFill>
+                  <a:srgbClr val="FFFFFF"/>
+                </a:solidFill>
+                <a:latin typeface="Arial"/>
+                <a:ea typeface="Microsoft JhengHei"/>
+              </a:rPr>
+              <a:t>場景放一顆 unk_c0(pci 301),但不建任何指向它的 NRT 條目 —— cell 真的存在、量測也看得到,表上就是完全查無。</a:t>
             </a:r>
           </a:p>
         </p:txBody>

</xml_diff>